<commit_message>
docs: bring every document in line with what was built
Stale statements found by searching all Markdown, corrected:
- spec 001 assumptions (auth and real email "out of scope") marked superseded by spec 002
- ingestion contract: Account.updated gained primary_contact
- 001 data model: pointer + summary of migrations 0005/0006 (new columns, tables, the global login_attempt)
- HANDOFF opens with "current state = CLOSED OUT section"; AGENTS.md read order covers both specs
- spec 002 status Draft -> Implemented (with its exceptions); data model lists the audit events actually
  written and no longer shows a "sending" state the code never persists; api-changes gains rate limiting + CLI
- README layout (auth/, tools/, e2e/, docker, docs, both specs); 001 quickstart (npm run e2e, send-test)
- DECK outline + rebuilt Pulse_deck.pptx: identity, send gate/demo mode, validated drafts, honest gaps

Backend 440 passed.

Co-Authored-By: Claude Sonnet 5.5 <noreply@anthropic.com>
</commit_message>
<xml_diff>
--- a/docs/Pulse_deck.pptx
+++ b/docs/Pulse_deck.pptx
@@ -3286,7 +3286,7 @@
               </a:defRPr>
             </a:pPr>
             <a:r>
-              <a:t>Two planted lost-renewal accounts not flagged → lead time not claimed. Diagnosed, documented (B-15).</a:t>
+              <a:t>Two planted lost-renewal accounts not flagged → lead time not claimed (B-15). A new small tenant gets almost nothing from the shared model (cold-start AUC 0.53). No real email sent and no real model call made — built and tested against stand-ins; containers never built (no Docker here).</a:t>
             </a:r>
           </a:p>
         </p:txBody>
@@ -4963,7 +4963,7 @@
               </a:defRPr>
             </a:pPr>
             <a:r>
-              <a:t>Drafts by default. Auto-send: per tenant, per play, opt-in, suppression + rate limit. SC-011.</a:t>
+              <a:t>Drafts by default. Auto-send: per tenant, per play, opt-in, suppression + rate limit. Real email only through a verified sender, never to an opted-out or contact-less account, and in demo mode (the default) never to a real customer. An ambiguous send is never retried.</a:t>
             </a:r>
           </a:p>
         </p:txBody>
@@ -5051,7 +5051,7 @@
               </a:defRPr>
             </a:pPr>
             <a:r>
-              <a:t>Point-in-time · model ranks/LLM writes · reviewed boundary · tenant isolation (RLS, mutation-verified) · explained outputs.</a:t>
+              <a:t>Point-in-time · model ranks/LLM writes (only from derived facts; output rejected if a number or claim is untraceable) · reviewed boundary · tenant isolation (RLS, mutation-verified; tenant from a verified session, never a header) · explained outputs.</a:t>
             </a:r>
           </a:p>
         </p:txBody>

</xml_diff>

<commit_message>
docs: re-shot walkthrough (docx/pdf), deck, Loom script, hosting guide, README and HANDOFF for the new model; containers re-verified
Co-Authored-By: Claude Sonnet 5.5 <noreply@anthropic.com>
Claude-Session: https://claude.ai/code/session_01SbRfaJikJiSq218rciPSuz
</commit_message>
<xml_diff>
--- a/docs/Pulse_deck.pptx
+++ b/docs/Pulse_deck.pptx
@@ -3286,7 +3286,7 @@
               </a:defRPr>
             </a:pPr>
             <a:r>
-              <a:t>Two planted lost-renewal accounts not flagged → lead time not claimed (B-15). A new small tenant gets almost nothing from the shared model (cold-start AUC 0.53). No real email sent and no real model call made — built and tested against stand-ins; containers built and run on arm64 only (browser suite passes against them).</a:t>
+              <a:t>The two planted lost-renewal accounts are not flagged out of sample, and they are poor tests (one is forced to churn by a rule no health signal shows; the other churned a year before its planted collapse) — so lead time is measured over every loss instead (B-33). About 70% of losses are not foreseeable from these signals. A new small tenant gets almost nothing from the shared model (cold-start AUC 0.46). Email was verified over real SMTP against a local mail server, including an unattended send, but no real mail provider has been used. Drafting ran for real against a free local model (20 of 20 drafts passed the guardrails); the Anthropic provider has not been run against the real API. Containers built and run on arm64 only (browser suite passes against them). Earlier-week scores are in-sample, for browsing only.</a:t>
             </a:r>
           </a:p>
         </p:txBody>
@@ -3374,7 +3374,7 @@
               </a:defRPr>
             </a:pPr>
             <a:r>
-              <a:t>Cycle is first to break (batched loading, more workers). Next: response-time feature work with held-out validation, uplift once intervention history exists.</a:t>
+              <a:t>Cycle is first to break (batched loading, more workers). Next: uplift once intervention history exists. More features would not help here — the existing ones already reconstruct the hidden health (R² 0.78) and adding the true health gained nothing.</a:t>
             </a:r>
           </a:p>
         </p:txBody>
@@ -3821,7 +3821,7 @@
                         <a:defRPr sz="1300"/>
                       </a:pPr>
                       <a:r>
-                        <a:t>35%</a:t>
+                        <a:t>67%</a:t>
                       </a:r>
                     </a:p>
                   </a:txBody>
@@ -3836,7 +3836,7 @@
                         <a:defRPr sz="1300"/>
                       </a:pPr>
                       <a:r>
-                        <a:t>$1,692,592</a:t>
+                        <a:t>$842,233</a:t>
                       </a:r>
                     </a:p>
                   </a:txBody>
@@ -3851,7 +3851,7 @@
                         <a:defRPr sz="1300"/>
                       </a:pPr>
                       <a:r>
-                        <a:t>15 d</a:t>
+                        <a:t>37 d</a:t>
                       </a:r>
                     </a:p>
                   </a:txBody>
@@ -3866,7 +3866,7 @@
                         <a:defRPr sz="1300"/>
                       </a:pPr>
                       <a:r>
-                        <a:t>usage decline</a:t>
+                        <a:t>commercial signals</a:t>
                       </a:r>
                     </a:p>
                   </a:txBody>
@@ -3881,7 +3881,7 @@
                         <a:defRPr sz="1300"/>
                       </a:pPr>
                       <a:r>
-                        <a:t>—</a:t>
+                        <a:t>+0.12</a:t>
                       </a:r>
                     </a:p>
                   </a:txBody>
@@ -3898,7 +3898,229 @@
                         <a:defRPr sz="1300"/>
                       </a:pPr>
                       <a:r>
+                        <a:t>Lakeshore Collective</a:t>
+                      </a:r>
+                    </a:p>
+                  </a:txBody>
+                  <a:tcPr/>
+                </a:tc>
+                <a:tc>
+                  <a:txBody>
+                    <a:bodyPr/>
+                    <a:lstStyle/>
+                    <a:p>
+                      <a:pPr>
+                        <a:defRPr sz="1300" b="1">
+                          <a:solidFill>
+                            <a:srgbClr val="B26A00"/>
+                          </a:solidFill>
+                        </a:defRPr>
+                      </a:pPr>
+                      <a:r>
+                        <a:t>amber</a:t>
+                      </a:r>
+                    </a:p>
+                  </a:txBody>
+                  <a:tcPr/>
+                </a:tc>
+                <a:tc>
+                  <a:txBody>
+                    <a:bodyPr/>
+                    <a:lstStyle/>
+                    <a:p>
+                      <a:pPr>
+                        <a:defRPr sz="1300"/>
+                      </a:pPr>
+                      <a:r>
+                        <a:t>17%</a:t>
+                      </a:r>
+                    </a:p>
+                  </a:txBody>
+                  <a:tcPr/>
+                </a:tc>
+                <a:tc>
+                  <a:txBody>
+                    <a:bodyPr/>
+                    <a:lstStyle/>
+                    <a:p>
+                      <a:pPr>
+                        <a:defRPr sz="1300"/>
+                      </a:pPr>
+                      <a:r>
+                        <a:t>$1,945,627</a:t>
+                      </a:r>
+                    </a:p>
+                  </a:txBody>
+                  <a:tcPr/>
+                </a:tc>
+                <a:tc>
+                  <a:txBody>
+                    <a:bodyPr/>
+                    <a:lstStyle/>
+                    <a:p>
+                      <a:pPr>
+                        <a:defRPr sz="1300"/>
+                      </a:pPr>
+                      <a:r>
+                        <a:t>63 d</a:t>
+                      </a:r>
+                    </a:p>
+                  </a:txBody>
+                  <a:tcPr/>
+                </a:tc>
+                <a:tc>
+                  <a:txBody>
+                    <a:bodyPr/>
+                    <a:lstStyle/>
+                    <a:p>
+                      <a:pPr>
+                        <a:defRPr sz="1300"/>
+                      </a:pPr>
+                      <a:r>
+                        <a:t>commercial signals</a:t>
+                      </a:r>
+                    </a:p>
+                  </a:txBody>
+                  <a:tcPr/>
+                </a:tc>
+                <a:tc>
+                  <a:txBody>
+                    <a:bodyPr/>
+                    <a:lstStyle/>
+                    <a:p>
+                      <a:pPr>
+                        <a:defRPr sz="1300"/>
+                      </a:pPr>
+                      <a:r>
+                        <a:t>-0.00</a:t>
+                      </a:r>
+                    </a:p>
+                  </a:txBody>
+                  <a:tcPr/>
+                </a:tc>
+              </a:tr>
+              <a:tr h="365760">
+                <a:tc>
+                  <a:txBody>
+                    <a:bodyPr/>
+                    <a:lstStyle/>
+                    <a:p>
+                      <a:pPr>
+                        <a:defRPr sz="1300"/>
+                      </a:pPr>
+                      <a:r>
                         <a:t>Windmere Capital</a:t>
+                      </a:r>
+                    </a:p>
+                  </a:txBody>
+                  <a:tcPr/>
+                </a:tc>
+                <a:tc>
+                  <a:txBody>
+                    <a:bodyPr/>
+                    <a:lstStyle/>
+                    <a:p>
+                      <a:pPr>
+                        <a:defRPr sz="1300" b="1">
+                          <a:solidFill>
+                            <a:srgbClr val="B26A00"/>
+                          </a:solidFill>
+                        </a:defRPr>
+                      </a:pPr>
+                      <a:r>
+                        <a:t>amber</a:t>
+                      </a:r>
+                    </a:p>
+                  </a:txBody>
+                  <a:tcPr/>
+                </a:tc>
+                <a:tc>
+                  <a:txBody>
+                    <a:bodyPr/>
+                    <a:lstStyle/>
+                    <a:p>
+                      <a:pPr>
+                        <a:defRPr sz="1300"/>
+                      </a:pPr>
+                      <a:r>
+                        <a:t>16%</a:t>
+                      </a:r>
+                    </a:p>
+                  </a:txBody>
+                  <a:tcPr/>
+                </a:tc>
+                <a:tc>
+                  <a:txBody>
+                    <a:bodyPr/>
+                    <a:lstStyle/>
+                    <a:p>
+                      <a:pPr>
+                        <a:defRPr sz="1300"/>
+                      </a:pPr>
+                      <a:r>
+                        <a:t>$1,981,373</a:t>
+                      </a:r>
+                    </a:p>
+                  </a:txBody>
+                  <a:tcPr/>
+                </a:tc>
+                <a:tc>
+                  <a:txBody>
+                    <a:bodyPr/>
+                    <a:lstStyle/>
+                    <a:p>
+                      <a:pPr>
+                        <a:defRPr sz="1300"/>
+                      </a:pPr>
+                      <a:r>
+                        <a:t>89 d</a:t>
+                      </a:r>
+                    </a:p>
+                  </a:txBody>
+                  <a:tcPr/>
+                </a:tc>
+                <a:tc>
+                  <a:txBody>
+                    <a:bodyPr/>
+                    <a:lstStyle/>
+                    <a:p>
+                      <a:pPr>
+                        <a:defRPr sz="1300"/>
+                      </a:pPr>
+                      <a:r>
+                        <a:t>commercial signals</a:t>
+                      </a:r>
+                    </a:p>
+                  </a:txBody>
+                  <a:tcPr/>
+                </a:tc>
+                <a:tc>
+                  <a:txBody>
+                    <a:bodyPr/>
+                    <a:lstStyle/>
+                    <a:p>
+                      <a:pPr>
+                        <a:defRPr sz="1300"/>
+                      </a:pPr>
+                      <a:r>
+                        <a:t>+0.10</a:t>
+                      </a:r>
+                    </a:p>
+                  </a:txBody>
+                  <a:tcPr/>
+                </a:tc>
+              </a:tr>
+              <a:tr h="365760">
+                <a:tc>
+                  <a:txBody>
+                    <a:bodyPr/>
+                    <a:lstStyle/>
+                    <a:p>
+                      <a:pPr>
+                        <a:defRPr sz="1300"/>
+                      </a:pPr>
+                      <a:r>
+                        <a:t>Pinnacle Estates</a:t>
                       </a:r>
                     </a:p>
                   </a:txBody>
@@ -3932,7 +4154,7 @@
                         <a:defRPr sz="1300"/>
                       </a:pPr>
                       <a:r>
-                        <a:t>35%</a:t>
+                        <a:t>23%</a:t>
                       </a:r>
                     </a:p>
                   </a:txBody>
@@ -3947,7 +4169,7 @@
                         <a:defRPr sz="1300"/>
                       </a:pPr>
                       <a:r>
-                        <a:t>$1,981,373</a:t>
+                        <a:t>$1,236,967</a:t>
                       </a:r>
                     </a:p>
                   </a:txBody>
@@ -3962,7 +4184,7 @@
                         <a:defRPr sz="1300"/>
                       </a:pPr>
                       <a:r>
-                        <a:t>60 d</a:t>
+                        <a:t>35 d</a:t>
                       </a:r>
                     </a:p>
                   </a:txBody>
@@ -3992,7 +4214,7 @@
                         <a:defRPr sz="1300"/>
                       </a:pPr>
                       <a:r>
-                        <a:t>—</a:t>
+                        <a:t>-0.02</a:t>
                       </a:r>
                     </a:p>
                   </a:txBody>
@@ -4009,7 +4231,229 @@
                         <a:defRPr sz="1300"/>
                       </a:pPr>
                       <a:r>
-                        <a:t>Lakeshore Collective</a:t>
+                        <a:t>Redwood Residential</a:t>
+                      </a:r>
+                    </a:p>
+                  </a:txBody>
+                  <a:tcPr/>
+                </a:tc>
+                <a:tc>
+                  <a:txBody>
+                    <a:bodyPr/>
+                    <a:lstStyle/>
+                    <a:p>
+                      <a:pPr>
+                        <a:defRPr sz="1300" b="1">
+                          <a:solidFill>
+                            <a:srgbClr val="B26A00"/>
+                          </a:solidFill>
+                        </a:defRPr>
+                      </a:pPr>
+                      <a:r>
+                        <a:t>amber</a:t>
+                      </a:r>
+                    </a:p>
+                  </a:txBody>
+                  <a:tcPr/>
+                </a:tc>
+                <a:tc>
+                  <a:txBody>
+                    <a:bodyPr/>
+                    <a:lstStyle/>
+                    <a:p>
+                      <a:pPr>
+                        <a:defRPr sz="1300"/>
+                      </a:pPr>
+                      <a:r>
+                        <a:t>20%</a:t>
+                      </a:r>
+                    </a:p>
+                  </a:txBody>
+                  <a:tcPr/>
+                </a:tc>
+                <a:tc>
+                  <a:txBody>
+                    <a:bodyPr/>
+                    <a:lstStyle/>
+                    <a:p>
+                      <a:pPr>
+                        <a:defRPr sz="1300"/>
+                      </a:pPr>
+                      <a:r>
+                        <a:t>$1,324,171</a:t>
+                      </a:r>
+                    </a:p>
+                  </a:txBody>
+                  <a:tcPr/>
+                </a:tc>
+                <a:tc>
+                  <a:txBody>
+                    <a:bodyPr/>
+                    <a:lstStyle/>
+                    <a:p>
+                      <a:pPr>
+                        <a:defRPr sz="1300"/>
+                      </a:pPr>
+                      <a:r>
+                        <a:t>61 d</a:t>
+                      </a:r>
+                    </a:p>
+                  </a:txBody>
+                  <a:tcPr/>
+                </a:tc>
+                <a:tc>
+                  <a:txBody>
+                    <a:bodyPr/>
+                    <a:lstStyle/>
+                    <a:p>
+                      <a:pPr>
+                        <a:defRPr sz="1300"/>
+                      </a:pPr>
+                      <a:r>
+                        <a:t>commercial signals</a:t>
+                      </a:r>
+                    </a:p>
+                  </a:txBody>
+                  <a:tcPr/>
+                </a:tc>
+                <a:tc>
+                  <a:txBody>
+                    <a:bodyPr/>
+                    <a:lstStyle/>
+                    <a:p>
+                      <a:pPr>
+                        <a:defRPr sz="1300"/>
+                      </a:pPr>
+                      <a:r>
+                        <a:t>+0.03</a:t>
+                      </a:r>
+                    </a:p>
+                  </a:txBody>
+                  <a:tcPr/>
+                </a:tc>
+              </a:tr>
+              <a:tr h="365760">
+                <a:tc>
+                  <a:txBody>
+                    <a:bodyPr/>
+                    <a:lstStyle/>
+                    <a:p>
+                      <a:pPr>
+                        <a:defRPr sz="1300"/>
+                      </a:pPr>
+                      <a:r>
+                        <a:t>Castlegate Estates</a:t>
+                      </a:r>
+                    </a:p>
+                  </a:txBody>
+                  <a:tcPr/>
+                </a:tc>
+                <a:tc>
+                  <a:txBody>
+                    <a:bodyPr/>
+                    <a:lstStyle/>
+                    <a:p>
+                      <a:pPr>
+                        <a:defRPr sz="1300" b="1">
+                          <a:solidFill>
+                            <a:srgbClr val="B26A00"/>
+                          </a:solidFill>
+                        </a:defRPr>
+                      </a:pPr>
+                      <a:r>
+                        <a:t>amber</a:t>
+                      </a:r>
+                    </a:p>
+                  </a:txBody>
+                  <a:tcPr/>
+                </a:tc>
+                <a:tc>
+                  <a:txBody>
+                    <a:bodyPr/>
+                    <a:lstStyle/>
+                    <a:p>
+                      <a:pPr>
+                        <a:defRPr sz="1300"/>
+                      </a:pPr>
+                      <a:r>
+                        <a:t>14%</a:t>
+                      </a:r>
+                    </a:p>
+                  </a:txBody>
+                  <a:tcPr/>
+                </a:tc>
+                <a:tc>
+                  <a:txBody>
+                    <a:bodyPr/>
+                    <a:lstStyle/>
+                    <a:p>
+                      <a:pPr>
+                        <a:defRPr sz="1300"/>
+                      </a:pPr>
+                      <a:r>
+                        <a:t>$1,692,592</a:t>
+                      </a:r>
+                    </a:p>
+                  </a:txBody>
+                  <a:tcPr/>
+                </a:tc>
+                <a:tc>
+                  <a:txBody>
+                    <a:bodyPr/>
+                    <a:lstStyle/>
+                    <a:p>
+                      <a:pPr>
+                        <a:defRPr sz="1300"/>
+                      </a:pPr>
+                      <a:r>
+                        <a:t>44 d</a:t>
+                      </a:r>
+                    </a:p>
+                  </a:txBody>
+                  <a:tcPr/>
+                </a:tc>
+                <a:tc>
+                  <a:txBody>
+                    <a:bodyPr/>
+                    <a:lstStyle/>
+                    <a:p>
+                      <a:pPr>
+                        <a:defRPr sz="1300"/>
+                      </a:pPr>
+                      <a:r>
+                        <a:t>commercial signals</a:t>
+                      </a:r>
+                    </a:p>
+                  </a:txBody>
+                  <a:tcPr/>
+                </a:tc>
+                <a:tc>
+                  <a:txBody>
+                    <a:bodyPr/>
+                    <a:lstStyle/>
+                    <a:p>
+                      <a:pPr>
+                        <a:defRPr sz="1300"/>
+                      </a:pPr>
+                      <a:r>
+                        <a:t>+0.00</a:t>
+                      </a:r>
+                    </a:p>
+                  </a:txBody>
+                  <a:tcPr/>
+                </a:tc>
+              </a:tr>
+              <a:tr h="365760">
+                <a:tc>
+                  <a:txBody>
+                    <a:bodyPr/>
+                    <a:lstStyle/>
+                    <a:p>
+                      <a:pPr>
+                        <a:defRPr sz="1300"/>
+                      </a:pPr>
+                      <a:r>
+                        <a:t>Pinnacle Capital</a:t>
                       </a:r>
                     </a:p>
                   </a:txBody>
@@ -4043,7 +4487,7 @@
                         <a:defRPr sz="1300"/>
                       </a:pPr>
                       <a:r>
-                        <a:t>35%</a:t>
+                        <a:t>33%</a:t>
                       </a:r>
                     </a:p>
                   </a:txBody>
@@ -4058,7 +4502,7 @@
                         <a:defRPr sz="1300"/>
                       </a:pPr>
                       <a:r>
-                        <a:t>$1,945,627</a:t>
+                        <a:t>$605,623</a:t>
                       </a:r>
                     </a:p>
                   </a:txBody>
@@ -4073,7 +4517,7 @@
                         <a:defRPr sz="1300"/>
                       </a:pPr>
                       <a:r>
-                        <a:t>34 d</a:t>
+                        <a:t>59 d</a:t>
                       </a:r>
                     </a:p>
                   </a:txBody>
@@ -4103,7 +4547,7 @@
                         <a:defRPr sz="1300"/>
                       </a:pPr>
                       <a:r>
-                        <a:t>—</a:t>
+                        <a:t>+0.02</a:t>
                       </a:r>
                     </a:p>
                   </a:txBody>
@@ -4120,7 +4564,7 @@
                         <a:defRPr sz="1300"/>
                       </a:pPr>
                       <a:r>
-                        <a:t>Pinnacle Estates</a:t>
+                        <a:t>Silverline Advisors</a:t>
                       </a:r>
                     </a:p>
                   </a:txBody>
@@ -4154,7 +4598,7 @@
                         <a:defRPr sz="1300"/>
                       </a:pPr>
                       <a:r>
-                        <a:t>35%</a:t>
+                        <a:t>24%</a:t>
                       </a:r>
                     </a:p>
                   </a:txBody>
@@ -4169,7 +4613,7 @@
                         <a:defRPr sz="1300"/>
                       </a:pPr>
                       <a:r>
-                        <a:t>$1,236,967</a:t>
+                        <a:t>$539,776</a:t>
                       </a:r>
                     </a:p>
                   </a:txBody>
@@ -4184,7 +4628,7 @@
                         <a:defRPr sz="1300"/>
                       </a:pPr>
                       <a:r>
-                        <a:t>6 d</a:t>
+                        <a:t>28 d</a:t>
                       </a:r>
                     </a:p>
                   </a:txBody>
@@ -4199,7 +4643,7 @@
                         <a:defRPr sz="1300"/>
                       </a:pPr>
                       <a:r>
-                        <a:t>usage decline</a:t>
+                        <a:t>commercial signals</a:t>
                       </a:r>
                     </a:p>
                   </a:txBody>
@@ -4214,451 +4658,7 @@
                         <a:defRPr sz="1300"/>
                       </a:pPr>
                       <a:r>
-                        <a:t>—</a:t>
-                      </a:r>
-                    </a:p>
-                  </a:txBody>
-                  <a:tcPr/>
-                </a:tc>
-              </a:tr>
-              <a:tr h="365760">
-                <a:tc>
-                  <a:txBody>
-                    <a:bodyPr/>
-                    <a:lstStyle/>
-                    <a:p>
-                      <a:pPr>
-                        <a:defRPr sz="1300"/>
-                      </a:pPr>
-                      <a:r>
-                        <a:t>Alderwood Management</a:t>
-                      </a:r>
-                    </a:p>
-                  </a:txBody>
-                  <a:tcPr/>
-                </a:tc>
-                <a:tc>
-                  <a:txBody>
-                    <a:bodyPr/>
-                    <a:lstStyle/>
-                    <a:p>
-                      <a:pPr>
-                        <a:defRPr sz="1300" b="1">
-                          <a:solidFill>
-                            <a:srgbClr val="C62828"/>
-                          </a:solidFill>
-                        </a:defRPr>
-                      </a:pPr>
-                      <a:r>
-                        <a:t>red</a:t>
-                      </a:r>
-                    </a:p>
-                  </a:txBody>
-                  <a:tcPr/>
-                </a:tc>
-                <a:tc>
-                  <a:txBody>
-                    <a:bodyPr/>
-                    <a:lstStyle/>
-                    <a:p>
-                      <a:pPr>
-                        <a:defRPr sz="1300"/>
-                      </a:pPr>
-                      <a:r>
-                        <a:t>35%</a:t>
-                      </a:r>
-                    </a:p>
-                  </a:txBody>
-                  <a:tcPr/>
-                </a:tc>
-                <a:tc>
-                  <a:txBody>
-                    <a:bodyPr/>
-                    <a:lstStyle/>
-                    <a:p>
-                      <a:pPr>
-                        <a:defRPr sz="1300"/>
-                      </a:pPr>
-                      <a:r>
-                        <a:t>$1,120,020</a:t>
-                      </a:r>
-                    </a:p>
-                  </a:txBody>
-                  <a:tcPr/>
-                </a:tc>
-                <a:tc>
-                  <a:txBody>
-                    <a:bodyPr/>
-                    <a:lstStyle/>
-                    <a:p>
-                      <a:pPr>
-                        <a:defRPr sz="1300"/>
-                      </a:pPr>
-                      <a:r>
-                        <a:t>24 d</a:t>
-                      </a:r>
-                    </a:p>
-                  </a:txBody>
-                  <a:tcPr/>
-                </a:tc>
-                <a:tc>
-                  <a:txBody>
-                    <a:bodyPr/>
-                    <a:lstStyle/>
-                    <a:p>
-                      <a:pPr>
-                        <a:defRPr sz="1300"/>
-                      </a:pPr>
-                      <a:r>
-                        <a:t>usage decline</a:t>
-                      </a:r>
-                    </a:p>
-                  </a:txBody>
-                  <a:tcPr/>
-                </a:tc>
-                <a:tc>
-                  <a:txBody>
-                    <a:bodyPr/>
-                    <a:lstStyle/>
-                    <a:p>
-                      <a:pPr>
-                        <a:defRPr sz="1300"/>
-                      </a:pPr>
-                      <a:r>
-                        <a:t>—</a:t>
-                      </a:r>
-                    </a:p>
-                  </a:txBody>
-                  <a:tcPr/>
-                </a:tc>
-              </a:tr>
-              <a:tr h="365760">
-                <a:tc>
-                  <a:txBody>
-                    <a:bodyPr/>
-                    <a:lstStyle/>
-                    <a:p>
-                      <a:pPr>
-                        <a:defRPr sz="1300"/>
-                      </a:pPr>
-                      <a:r>
-                        <a:t>Northstar Realty</a:t>
-                      </a:r>
-                    </a:p>
-                  </a:txBody>
-                  <a:tcPr/>
-                </a:tc>
-                <a:tc>
-                  <a:txBody>
-                    <a:bodyPr/>
-                    <a:lstStyle/>
-                    <a:p>
-                      <a:pPr>
-                        <a:defRPr sz="1300" b="1">
-                          <a:solidFill>
-                            <a:srgbClr val="C62828"/>
-                          </a:solidFill>
-                        </a:defRPr>
-                      </a:pPr>
-                      <a:r>
-                        <a:t>red</a:t>
-                      </a:r>
-                    </a:p>
-                  </a:txBody>
-                  <a:tcPr/>
-                </a:tc>
-                <a:tc>
-                  <a:txBody>
-                    <a:bodyPr/>
-                    <a:lstStyle/>
-                    <a:p>
-                      <a:pPr>
-                        <a:defRPr sz="1300"/>
-                      </a:pPr>
-                      <a:r>
-                        <a:t>35%</a:t>
-                      </a:r>
-                    </a:p>
-                  </a:txBody>
-                  <a:tcPr/>
-                </a:tc>
-                <a:tc>
-                  <a:txBody>
-                    <a:bodyPr/>
-                    <a:lstStyle/>
-                    <a:p>
-                      <a:pPr>
-                        <a:defRPr sz="1300"/>
-                      </a:pPr>
-                      <a:r>
-                        <a:t>$2,135,628</a:t>
-                      </a:r>
-                    </a:p>
-                  </a:txBody>
-                  <a:tcPr/>
-                </a:tc>
-                <a:tc>
-                  <a:txBody>
-                    <a:bodyPr/>
-                    <a:lstStyle/>
-                    <a:p>
-                      <a:pPr>
-                        <a:defRPr sz="1300"/>
-                      </a:pPr>
-                      <a:r>
-                        <a:t>156 d</a:t>
-                      </a:r>
-                    </a:p>
-                  </a:txBody>
-                  <a:tcPr/>
-                </a:tc>
-                <a:tc>
-                  <a:txBody>
-                    <a:bodyPr/>
-                    <a:lstStyle/>
-                    <a:p>
-                      <a:pPr>
-                        <a:defRPr sz="1300"/>
-                      </a:pPr>
-                      <a:r>
-                        <a:t>commercial signals</a:t>
-                      </a:r>
-                    </a:p>
-                  </a:txBody>
-                  <a:tcPr/>
-                </a:tc>
-                <a:tc>
-                  <a:txBody>
-                    <a:bodyPr/>
-                    <a:lstStyle/>
-                    <a:p>
-                      <a:pPr>
-                        <a:defRPr sz="1300"/>
-                      </a:pPr>
-                      <a:r>
-                        <a:t>—</a:t>
-                      </a:r>
-                    </a:p>
-                  </a:txBody>
-                  <a:tcPr/>
-                </a:tc>
-              </a:tr>
-              <a:tr h="365760">
-                <a:tc>
-                  <a:txBody>
-                    <a:bodyPr/>
-                    <a:lstStyle/>
-                    <a:p>
-                      <a:pPr>
-                        <a:defRPr sz="1300"/>
-                      </a:pPr>
-                      <a:r>
-                        <a:t>Sunvale Partners 11</a:t>
-                      </a:r>
-                    </a:p>
-                  </a:txBody>
-                  <a:tcPr/>
-                </a:tc>
-                <a:tc>
-                  <a:txBody>
-                    <a:bodyPr/>
-                    <a:lstStyle/>
-                    <a:p>
-                      <a:pPr>
-                        <a:defRPr sz="1300" b="1">
-                          <a:solidFill>
-                            <a:srgbClr val="C62828"/>
-                          </a:solidFill>
-                        </a:defRPr>
-                      </a:pPr>
-                      <a:r>
-                        <a:t>red</a:t>
-                      </a:r>
-                    </a:p>
-                  </a:txBody>
-                  <a:tcPr/>
-                </a:tc>
-                <a:tc>
-                  <a:txBody>
-                    <a:bodyPr/>
-                    <a:lstStyle/>
-                    <a:p>
-                      <a:pPr>
-                        <a:defRPr sz="1300"/>
-                      </a:pPr>
-                      <a:r>
-                        <a:t>35%</a:t>
-                      </a:r>
-                    </a:p>
-                  </a:txBody>
-                  <a:tcPr/>
-                </a:tc>
-                <a:tc>
-                  <a:txBody>
-                    <a:bodyPr/>
-                    <a:lstStyle/>
-                    <a:p>
-                      <a:pPr>
-                        <a:defRPr sz="1300"/>
-                      </a:pPr>
-                      <a:r>
-                        <a:t>$1,350,064</a:t>
-                      </a:r>
-                    </a:p>
-                  </a:txBody>
-                  <a:tcPr/>
-                </a:tc>
-                <a:tc>
-                  <a:txBody>
-                    <a:bodyPr/>
-                    <a:lstStyle/>
-                    <a:p>
-                      <a:pPr>
-                        <a:defRPr sz="1300"/>
-                      </a:pPr>
-                      <a:r>
-                        <a:t>70 d</a:t>
-                      </a:r>
-                    </a:p>
-                  </a:txBody>
-                  <a:tcPr/>
-                </a:tc>
-                <a:tc>
-                  <a:txBody>
-                    <a:bodyPr/>
-                    <a:lstStyle/>
-                    <a:p>
-                      <a:pPr>
-                        <a:defRPr sz="1300"/>
-                      </a:pPr>
-                      <a:r>
-                        <a:t>usage decline</a:t>
-                      </a:r>
-                    </a:p>
-                  </a:txBody>
-                  <a:tcPr/>
-                </a:tc>
-                <a:tc>
-                  <a:txBody>
-                    <a:bodyPr/>
-                    <a:lstStyle/>
-                    <a:p>
-                      <a:pPr>
-                        <a:defRPr sz="1300"/>
-                      </a:pPr>
-                      <a:r>
-                        <a:t>—</a:t>
-                      </a:r>
-                    </a:p>
-                  </a:txBody>
-                  <a:tcPr/>
-                </a:tc>
-              </a:tr>
-              <a:tr h="365760">
-                <a:tc>
-                  <a:txBody>
-                    <a:bodyPr/>
-                    <a:lstStyle/>
-                    <a:p>
-                      <a:pPr>
-                        <a:defRPr sz="1300"/>
-                      </a:pPr>
-                      <a:r>
-                        <a:t>Ironwood Estates</a:t>
-                      </a:r>
-                    </a:p>
-                  </a:txBody>
-                  <a:tcPr/>
-                </a:tc>
-                <a:tc>
-                  <a:txBody>
-                    <a:bodyPr/>
-                    <a:lstStyle/>
-                    <a:p>
-                      <a:pPr>
-                        <a:defRPr sz="1300" b="1">
-                          <a:solidFill>
-                            <a:srgbClr val="C62828"/>
-                          </a:solidFill>
-                        </a:defRPr>
-                      </a:pPr>
-                      <a:r>
-                        <a:t>red</a:t>
-                      </a:r>
-                    </a:p>
-                  </a:txBody>
-                  <a:tcPr/>
-                </a:tc>
-                <a:tc>
-                  <a:txBody>
-                    <a:bodyPr/>
-                    <a:lstStyle/>
-                    <a:p>
-                      <a:pPr>
-                        <a:defRPr sz="1300"/>
-                      </a:pPr>
-                      <a:r>
-                        <a:t>35%</a:t>
-                      </a:r>
-                    </a:p>
-                  </a:txBody>
-                  <a:tcPr/>
-                </a:tc>
-                <a:tc>
-                  <a:txBody>
-                    <a:bodyPr/>
-                    <a:lstStyle/>
-                    <a:p>
-                      <a:pPr>
-                        <a:defRPr sz="1300"/>
-                      </a:pPr>
-                      <a:r>
-                        <a:t>$900,182</a:t>
-                      </a:r>
-                    </a:p>
-                  </a:txBody>
-                  <a:tcPr/>
-                </a:tc>
-                <a:tc>
-                  <a:txBody>
-                    <a:bodyPr/>
-                    <a:lstStyle/>
-                    <a:p>
-                      <a:pPr>
-                        <a:defRPr sz="1300"/>
-                      </a:pPr>
-                      <a:r>
-                        <a:t>overdue 6 d</a:t>
-                      </a:r>
-                    </a:p>
-                  </a:txBody>
-                  <a:tcPr/>
-                </a:tc>
-                <a:tc>
-                  <a:txBody>
-                    <a:bodyPr/>
-                    <a:lstStyle/>
-                    <a:p>
-                      <a:pPr>
-                        <a:defRPr sz="1300"/>
-                      </a:pPr>
-                      <a:r>
-                        <a:t>usage decline</a:t>
-                      </a:r>
-                    </a:p>
-                  </a:txBody>
-                  <a:tcPr/>
-                </a:tc>
-                <a:tc>
-                  <a:txBody>
-                    <a:bodyPr/>
-                    <a:lstStyle/>
-                    <a:p>
-                      <a:pPr>
-                        <a:defRPr sz="1300"/>
-                      </a:pPr>
-                      <a:r>
-                        <a:t>—</a:t>
+                        <a:t>-0.01</a:t>
                       </a:r>
                     </a:p>
                   </a:txBody>
@@ -4699,7 +4699,7 @@
               </a:defRPr>
             </a:pPr>
             <a:r>
-              <a:t>12 accounts in this week's queue; 2490 more scored but below the capacity cut. Real data from the running system.</a:t>
+              <a:t>12 accounts in this week's queue; 2254 more scored but below the capacity cut. Real data from the running system.</a:t>
             </a:r>
           </a:p>
         </p:txBody>
@@ -5139,7 +5139,7 @@
               </a:defRPr>
             </a:pPr>
             <a:r>
-              <a:t>Precision@100 0.29 vs 0.02 baseline (~12×; range 0.22–0.33 by row order); AUC 0.69; promotion is gated on beating the baseline at the operating point.</a:t>
+              <a:t>Rolling backtest (4 folds, last 52 weeks, each fold scored by a model that saw only what was known then): ROC-AUC 0.661, against 0.673 for an oracle that knows every account's hidden health — on this data 0.7 is close to the ceiling. Lead time over all 390 losses: at the amber line (≥10% risk, 4.6% of account-weeks) 32% flagged, median 72 days ahead; oracle 33%. Precision@100 about 0.5 vs 0.02 for the heuristic on the latest block (one draw). Promotion is gated on beating the baseline at the operating point.</a:t>
             </a:r>
           </a:p>
         </p:txBody>

</xml_diff>

<commit_message>
docs: deck and Loom script for the seed path (15 s load, dry-run timings); ignore local submission drafts
Co-Authored-By: Claude Sonnet 5.5 <noreply@anthropic.com>
Claude-Session: https://claude.ai/code/session_01SbRfaJikJiSq218rciPSuz
</commit_message>
<xml_diff>
--- a/docs/Pulse_deck.pptx
+++ b/docs/Pulse_deck.pptx
@@ -16,6 +16,7 @@
     <p:sldId id="264" r:id="rId15"/>
     <p:sldId id="265" r:id="rId16"/>
     <p:sldId id="266" r:id="rId17"/>
+    <p:sldId id="267" r:id="rId18"/>
   </p:sldIdLst>
   <p:sldSz cx="12192000" cy="6858000" type="screen4x3"/>
   <p:notesSz cx="6858000" cy="9144000"/>
@@ -3251,7 +3252,7 @@
               </a:defRPr>
             </a:pPr>
             <a:r>
-              <a:t>9. What we are honest about</a:t>
+              <a:t>9. Try it in minutes</a:t>
             </a:r>
           </a:p>
         </p:txBody>
@@ -3286,7 +3287,7 @@
               </a:defRPr>
             </a:pPr>
             <a:r>
-              <a:t>The two planted lost-renewal accounts are not flagged out of sample, and they are poor tests (one is forced to churn by a rule no health signal shows; the other churned a year before its planted collapse) — so lead time is measured over every loss instead (B-33). About 70% of losses are not foreseeable from these signals. A new small tenant gets almost nothing from the shared model (cold-start AUC 0.46). Email was verified over real SMTP against a local mail server, including an unattended send, but no real mail provider has been used. Drafting ran for real against a free local model (20 of 20 drafts passed the guardrails); the Anthropic provider has not been run against the real API. Containers built and run on arm64 only (browser suite passes against them). Earlier-week scores are in-sample, for browsing only.</a:t>
+              <a:t>A reviewer-style dry run from a clean clone measured the old path: 7 min 37 s to build, then 10 to 46 minutes of backfill before the demo had any history. Now `docker compose up` plus `load-seed` loads a checksummed 51 MB seed in 15 s, history included; 13 of 13 browser scenarios pass against it. A single-service image (237 MB RAM, empty database to serving in 17 s) and a free-tier blueprint are prepared and tested in Docker; deployment status and the link are in the submission email.</a:t>
             </a:r>
           </a:p>
         </p:txBody>
@@ -3339,7 +3340,95 @@
               </a:defRPr>
             </a:pPr>
             <a:r>
-              <a:t>10. 10× and what's next</a:t>
+              <a:t>10. What we are honest about</a:t>
+            </a:r>
+          </a:p>
+        </p:txBody>
+      </p:sp>
+      <p:sp>
+        <p:nvSpPr>
+          <p:cNvPr id="3" name="TextBox 2"/>
+          <p:cNvSpPr txBox="1"/>
+          <p:nvPr/>
+        </p:nvSpPr>
+        <p:spPr>
+          <a:xfrm>
+            <a:off x="640080" y="1463040"/>
+            <a:ext cx="10881360" cy="4114800"/>
+          </a:xfrm>
+          <a:prstGeom prst="rect">
+            <a:avLst/>
+          </a:prstGeom>
+          <a:noFill/>
+        </p:spPr>
+        <p:txBody>
+          <a:bodyPr wrap="square">
+            <a:spAutoFit/>
+          </a:bodyPr>
+          <a:lstStyle/>
+          <a:p>
+            <a:pPr>
+              <a:defRPr sz="2200" b="0">
+                <a:solidFill>
+                  <a:srgbClr val="1B1F2A"/>
+                </a:solidFill>
+              </a:defRPr>
+            </a:pPr>
+            <a:r>
+              <a:t>The two planted lost-renewal accounts are not flagged out of sample, and they are poor tests (one is forced to churn by a rule no health signal shows; the other churned a year before its planted collapse) — so lead time is measured over every loss instead (B-33). About 70% of losses are not foreseeable from these signals. A new small tenant gets almost nothing from the shared model (cold-start AUC 0.46). Email was verified over real SMTP against a local mail server, including an unattended send, but no real mail provider has been used. Drafting ran for real against a free local model (20 of 20 drafts passed the guardrails); the Anthropic provider has not been run against the real API. Containers built and run on arm64 only (browser suite passes against them). Earlier-week scores are in-sample, for browsing only.</a:t>
+            </a:r>
+          </a:p>
+        </p:txBody>
+      </p:sp>
+    </p:spTree>
+  </p:cSld>
+  <p:clrMapOvr>
+    <a:masterClrMapping/>
+  </p:clrMapOvr>
+</p:sld>
+</file>
+
+<file path=ppt/slides/slide12.xml><?xml version="1.0" encoding="utf-8"?>
+<p:sld xmlns:a="http://schemas.openxmlformats.org/drawingml/2006/main" xmlns:p="http://schemas.openxmlformats.org/presentationml/2006/main" xmlns:r="http://schemas.openxmlformats.org/officeDocument/2006/relationships">
+  <p:cSld>
+    <p:spTree>
+      <p:nvGrpSpPr>
+        <p:cNvPr id="1" name=""/>
+        <p:cNvGrpSpPr/>
+        <p:nvPr/>
+      </p:nvGrpSpPr>
+      <p:grpSpPr/>
+      <p:sp>
+        <p:nvSpPr>
+          <p:cNvPr id="2" name="TextBox 1"/>
+          <p:cNvSpPr txBox="1"/>
+          <p:nvPr/>
+        </p:nvSpPr>
+        <p:spPr>
+          <a:xfrm>
+            <a:off x="640080" y="457200"/>
+            <a:ext cx="10881360" cy="822960"/>
+          </a:xfrm>
+          <a:prstGeom prst="rect">
+            <a:avLst/>
+          </a:prstGeom>
+          <a:noFill/>
+        </p:spPr>
+        <p:txBody>
+          <a:bodyPr wrap="square">
+            <a:spAutoFit/>
+          </a:bodyPr>
+          <a:lstStyle/>
+          <a:p>
+            <a:pPr>
+              <a:defRPr sz="3200" b="1">
+                <a:solidFill>
+                  <a:srgbClr val="1F5FBF"/>
+                </a:solidFill>
+              </a:defRPr>
+            </a:pPr>
+            <a:r>
+              <a:t>11. 10× and what's next</a:t>
             </a:r>
           </a:p>
         </p:txBody>

</xml_diff>

<commit_message>
docs: rebuild the deck with the hosted demo, Groq-written drafts and final test counts; plain text on slides
Co-Authored-By: Claude Sonnet 5.5 <noreply@anthropic.com>
Claude-Session: https://claude.ai/code/session_01SbRfaJikJiSq218rciPSuz
</commit_message>
<xml_diff>
--- a/docs/Pulse_deck.pptx
+++ b/docs/Pulse_deck.pptx
@@ -3287,7 +3287,7 @@
               </a:defRPr>
             </a:pPr>
             <a:r>
-              <a:t>A reviewer-style dry run from a clean clone measured the old path: 7 min 37 s to build, then 10 to 46 minutes of backfill before the demo had any history. Now `docker compose up` plus `load-seed` loads a checksummed 51 MB seed in 15 s, history included; 13 of 13 browser scenarios pass against it. A single-service image (237 MB RAM, empty database to serving in 17 s) and a free-tier blueprint are prepared and tested in Docker; deployment status and the link are in the submission email.</a:t>
+              <a:t>Two ways in. Hosted: a free Render service with a free Postgres (link and sign-in are in the submission email); it sleeps when idle, so the first load can take about a minute (measured: 48 s), and its database lasts about 30 days. Local: docker compose up plus load-seed loads a checksummed 51 MB seed in 15 s, history included. The old path measured 7 min 37 s to build plus 10 to 46 minutes of backfill. Verified: backend 602 tests, frontend 49, 13 of 13 browser scenarios in real Chrome; the hosted site was checked in a browser after deploy.</a:t>
             </a:r>
           </a:p>
         </p:txBody>
@@ -3375,7 +3375,7 @@
               </a:defRPr>
             </a:pPr>
             <a:r>
-              <a:t>The two planted lost-renewal accounts are not flagged out of sample, and they are poor tests (one is forced to churn by a rule no health signal shows; the other churned a year before its planted collapse) — so lead time is measured over every loss instead (B-33). About 70% of losses are not foreseeable from these signals. A new small tenant gets almost nothing from the shared model (cold-start AUC 0.46). Email was verified over real SMTP against a local mail server, including an unattended send, but no real mail provider has been used. Drafting ran for real against a free local model (20 of 20 drafts passed the guardrails); the Anthropic provider has not been run against the real API. Containers built and run on arm64 only (browser suite passes against them). Earlier-week scores are in-sample, for browsing only.</a:t>
+              <a:t>The two planted lost-renewal accounts are not flagged out of sample, and they are poor tests (one is forced to churn by a rule no health signal shows; the other churned a year before its planted collapse) — so lead time is measured over every loss instead (B-33). About 70% of losses are not foreseeable from these signals. A new small tenant gets almost nothing from the shared model (cold-start AUC 0.46). Drafts: 91 of the 106 in the demo were written by a free Groq model (qwen/qwen3.8-27b) in one real cycle, labelled "Drafted by llm"; 15 are templates; the guardrail rejected 3 model replies. The hosted demo shows those saved results — no background worker runs on the free tier. Email was verified over real SMTP against a local mail server, including an unattended send, but no real mail provider has been used; the Anthropic API has not been run. Earlier-week scores are in-sample, for browsing only.</a:t>
             </a:r>
           </a:p>
         </p:txBody>
@@ -4964,7 +4964,7 @@
               </a:defRPr>
             </a:pPr>
             <a:r>
-              <a:t>Ingest → score → detect change → draft → record. Run log shows what it did *and what it declined, and why*.</a:t>
+              <a:t>Ingest → score → detect change → draft → record. Run log shows what it did and what it declined, and why.</a:t>
             </a:r>
           </a:p>
         </p:txBody>

</xml_diff>